<commit_message>
Refactor traffic and pollution models for improved data handling and visualization; remove deprecated code and enhance UI layout
</commit_message>
<xml_diff>
--- a/PenangAir_Tutorial_NonProgrammer_Fixed.pptx
+++ b/PenangAir_Tutorial_NonProgrammer_Fixed.pptx
@@ -26,6 +26,7 @@
     <p:sldId id="274" r:id="rId26"/>
     <p:sldId id="275" r:id="rId27"/>
     <p:sldId id="276" r:id="rId28"/>
+    <p:sldId id="289" r:id="rId41"/>
     <p:sldId id="277" r:id="rId29"/>
     <p:sldId id="278" r:id="rId30"/>
     <p:sldId id="279" r:id="rId31"/>
@@ -3691,7 +3692,7 @@
           <a:lstStyle/>
           <a:p>
             <a:r>
-              <a:t>5. The ON/OFF Switch: 'tttt'</a:t>
+              <a:t>5. The ON/OFF Switch: 'use_traffic_data'</a:t>
             </a:r>
           </a:p>
         </p:txBody>
@@ -3723,23 +3724,23 @@
               <a:defRPr sz="1800"/>
             </a:pPr>
             <a:r>
-              <a:t>tttt = 1 → YES, use REAL traffic from traffic_counts.csv</a:t>
-            </a:r>
-          </a:p>
-          <a:p>
-            <a:pPr>
-              <a:defRPr sz="1800"/>
-            </a:pPr>
-            <a:r>
-              <a:t>tttt = 0 → NO, use made-up/default traffic instead</a:t>
-            </a:r>
-          </a:p>
-          <a:p>
-            <a:pPr>
-              <a:defRPr sz="1800"/>
-            </a:pPr>
-            <a:r>
-              <a:t>It's just an ON/OFF switch (toggle). Set to 1 in the model.</a:t>
+              <a:t>use_traffic_data = 1 → YES, use REAL traffic from traffic_counts.csv</a:t>
+            </a:r>
+          </a:p>
+          <a:p>
+            <a:pPr>
+              <a:defRPr sz="1800"/>
+            </a:pPr>
+            <a:r>
+              <a:t>use_traffic_data = 0 → NO, use a SMALL RANDOM default fleet (90 vehicles), scattered over all road types → much less traffic, weaker/diffuse pollution</a:t>
+            </a:r>
+          </a:p>
+          <a:p>
+            <a:pPr>
+              <a:defRPr sz="1800"/>
+            </a:pPr>
+            <a:r>
+              <a:t>It's just an ON/OFF switch (toggle). Set to 1 in the model.  Normal mode = 1 (real CSV data); 0 = sparse random test fleet.</a:t>
             </a:r>
           </a:p>
           <a:p>
@@ -4904,77 +4905,755 @@
       <p:grpSpPr/>
       <p:sp>
         <p:nvSpPr>
-          <p:cNvPr id="2" name="Title 1"/>
-          <p:cNvSpPr>
-            <a:spLocks noGrp="1"/>
-          </p:cNvSpPr>
-          <p:nvPr>
-            <p:ph type="title"/>
-          </p:nvPr>
-        </p:nvSpPr>
-        <p:spPr/>
-        <p:txBody>
-          <a:bodyPr/>
-          <a:lstStyle/>
-          <a:p>
-            <a:r>
-              <a:t>9. agents/visualization.gaml – What We See</a:t>
-            </a:r>
-          </a:p>
-        </p:txBody>
-      </p:sp>
-      <p:sp>
-        <p:nvSpPr>
-          <p:cNvPr id="3" name="Content Placeholder 2"/>
-          <p:cNvSpPr>
-            <a:spLocks noGrp="1"/>
-          </p:cNvSpPr>
-          <p:nvPr>
-            <p:ph idx="1"/>
-          </p:nvPr>
-        </p:nvSpPr>
-        <p:spPr/>
-        <p:txBody>
-          <a:bodyPr/>
-          <a:lstStyle/>
-          <a:p>
-            <a:pPr>
-              <a:defRPr sz="1800"/>
-            </a:pPr>
-            <a:r>
-              <a:t>Purpose: Turns numbers/agents into a VISUAL MAP + CHARTS (the GUI you see).</a:t>
-            </a:r>
-          </a:p>
-          <a:p>
-            <a:pPr>
-              <a:defRPr sz="1800"/>
-            </a:pPr>
-            <a:r>
-              <a:t>Shows: Penang map background, roads, buildings, vehicles moving, pollution layer (colours), study boundary.</a:t>
-            </a:r>
-          </a:p>
-          <a:p>
-            <a:pPr>
-              <a:defRPr sz="1800"/>
-            </a:pPr>
-            <a:r>
-              <a:t>Charts: AQI/pollution over TIME (line graph).</a:t>
-            </a:r>
-          </a:p>
-          <a:p>
-            <a:pPr>
-              <a:defRPr sz="1800"/>
-            </a:pPr>
-            <a:r>
-              <a:t>UI: Indicators (Time), progress bars (vehicle counts/mix).</a:t>
-            </a:r>
-          </a:p>
-          <a:p>
-            <a:pPr>
-              <a:defRPr sz="1800"/>
-            </a:pPr>
-            <a:r>
-              <a:t>Key Idea: Makes the invisible (pollution levels) VISIBLE on screen.</a:t>
+          <p:cNvPr id="2" name="TextBox 1"/>
+          <p:cNvSpPr txBox="1"/>
+          <p:nvPr/>
+        </p:nvSpPr>
+        <p:spPr>
+          <a:xfrm>
+            <a:off x="457200" y="320040"/>
+            <a:ext cx="8229600" cy="640080"/>
+          </a:xfrm>
+          <a:prstGeom prst="rect">
+            <a:avLst/>
+          </a:prstGeom>
+          <a:noFill/>
+        </p:spPr>
+        <p:txBody>
+          <a:bodyPr wrap="none">
+            <a:spAutoFit/>
+          </a:bodyPr>
+          <a:lstStyle/>
+          <a:p>
+            <a:pPr>
+              <a:defRPr sz="2800" b="1">
+                <a:solidFill>
+                  <a:srgbClr val="1A1A1A"/>
+                </a:solidFill>
+              </a:defRPr>
+            </a:pPr>
+            <a:r>
+              <a:t>Emissions by Vehicle Type (per km)</a:t>
+            </a:r>
+          </a:p>
+        </p:txBody>
+      </p:sp>
+      <p:sp>
+        <p:nvSpPr>
+          <p:cNvPr id="3" name="TextBox 2"/>
+          <p:cNvSpPr txBox="1"/>
+          <p:nvPr/>
+        </p:nvSpPr>
+        <p:spPr>
+          <a:xfrm>
+            <a:off x="548640" y="1005840"/>
+            <a:ext cx="8046720" cy="1463040"/>
+          </a:xfrm>
+          <a:prstGeom prst="rect">
+            <a:avLst/>
+          </a:prstGeom>
+          <a:noFill/>
+        </p:spPr>
+        <p:txBody>
+          <a:bodyPr wrap="square">
+            <a:spAutoFit/>
+          </a:bodyPr>
+          <a:lstStyle/>
+          <a:p>
+            <a:pPr>
+              <a:defRPr sz="1500">
+                <a:solidFill>
+                  <a:srgbClr val="222222"/>
+                </a:solidFill>
+              </a:defRPr>
+            </a:pPr>
+            <a:r>
+              <a:t>Each vehicle emits pollutants as it travels. Per-km factors (published values):</a:t>
+            </a:r>
+          </a:p>
+          <a:p>
+            <a:pPr>
+              <a:defRPr sz="1500">
+                <a:solidFill>
+                  <a:srgbClr val="222222"/>
+                </a:solidFill>
+              </a:defRPr>
+            </a:pPr>
+            <a:r>
+              <a:t>Heat-map weight = (PM + NOx) x 3.0 x EMISSION_SCALE.</a:t>
+            </a:r>
+          </a:p>
+          <a:p>
+            <a:pPr>
+              <a:defRPr sz="1500">
+                <a:solidFill>
+                  <a:srgbClr val="222222"/>
+                </a:solidFill>
+              </a:defRPr>
+            </a:pPr>
+            <a:r>
+              <a:t>EMISSION_SCALE is the magnitude knob: lowered from 0.2 to 0.15 (about 25% less).</a:t>
+            </a:r>
+          </a:p>
+          <a:p>
+            <a:pPr>
+              <a:defRPr sz="1500">
+                <a:solidFill>
+                  <a:srgbClr val="222222"/>
+                </a:solidFill>
+              </a:defRPr>
+            </a:pPr>
+            <a:r>
+              <a:t>Electric vehicles emit only 10% of their class factor.</a:t>
+            </a:r>
+          </a:p>
+        </p:txBody>
+      </p:sp>
+      <p:graphicFrame>
+        <p:nvGraphicFramePr>
+          <p:cNvPr id="4" name="Table 3"/>
+          <p:cNvGraphicFramePr>
+            <a:graphicFrameLocks noGrp="1"/>
+          </p:cNvGraphicFramePr>
+          <p:nvPr/>
+        </p:nvGraphicFramePr>
+        <p:xfrm>
+          <a:off x="548640" y="2560320"/>
+          <a:ext cx="8046720" cy="2103120"/>
+        </p:xfrm>
+        <a:graphic>
+          <a:graphicData uri="http://schemas.openxmlformats.org/drawingml/2006/table">
+            <a:tbl>
+              <a:tblPr firstRow="1" bandRow="1">
+                <a:tableStyleId>{5C22544A-7EE6-4342-B048-85BDC9FD1C3A}</a:tableStyleId>
+              </a:tblPr>
+              <a:tblGrid>
+                <a:gridCol w="1609344"/>
+                <a:gridCol w="1609344"/>
+                <a:gridCol w="1609344"/>
+                <a:gridCol w="1609344"/>
+                <a:gridCol w="1609344"/>
+              </a:tblGrid>
+              <a:tr h="457200">
+                <a:tc>
+                  <a:txBody>
+                    <a:bodyPr/>
+                    <a:lstStyle/>
+                    <a:p>
+                      <a:pPr>
+                        <a:defRPr sz="1400" b="1">
+                          <a:solidFill>
+                            <a:srgbClr val="FFFFFF"/>
+                          </a:solidFill>
+                        </a:defRPr>
+                      </a:pPr>
+                      <a:r>
+                        <a:t>Vehicle</a:t>
+                      </a:r>
+                    </a:p>
+                  </a:txBody>
+                  <a:tcPr>
+                    <a:solidFill>
+                      <a:srgbClr val="4466AA"/>
+                    </a:solidFill>
+                  </a:tcPr>
+                </a:tc>
+                <a:tc>
+                  <a:txBody>
+                    <a:bodyPr/>
+                    <a:lstStyle/>
+                    <a:p>
+                      <a:pPr>
+                        <a:defRPr sz="1400" b="1">
+                          <a:solidFill>
+                            <a:srgbClr val="FFFFFF"/>
+                          </a:solidFill>
+                        </a:defRPr>
+                      </a:pPr>
+                      <a:r>
+                        <a:t>CO (g/km)</a:t>
+                      </a:r>
+                    </a:p>
+                  </a:txBody>
+                  <a:tcPr>
+                    <a:solidFill>
+                      <a:srgbClr val="4466AA"/>
+                    </a:solidFill>
+                  </a:tcPr>
+                </a:tc>
+                <a:tc>
+                  <a:txBody>
+                    <a:bodyPr/>
+                    <a:lstStyle/>
+                    <a:p>
+                      <a:pPr>
+                        <a:defRPr sz="1400" b="1">
+                          <a:solidFill>
+                            <a:srgbClr val="FFFFFF"/>
+                          </a:solidFill>
+                        </a:defRPr>
+                      </a:pPr>
+                      <a:r>
+                        <a:t>NOx (g/km)</a:t>
+                      </a:r>
+                    </a:p>
+                  </a:txBody>
+                  <a:tcPr>
+                    <a:solidFill>
+                      <a:srgbClr val="4466AA"/>
+                    </a:solidFill>
+                  </a:tcPr>
+                </a:tc>
+                <a:tc>
+                  <a:txBody>
+                    <a:bodyPr/>
+                    <a:lstStyle/>
+                    <a:p>
+                      <a:pPr>
+                        <a:defRPr sz="1400" b="1">
+                          <a:solidFill>
+                            <a:srgbClr val="FFFFFF"/>
+                          </a:solidFill>
+                        </a:defRPr>
+                      </a:pPr>
+                      <a:r>
+                        <a:t>SO2 (g/km)</a:t>
+                      </a:r>
+                    </a:p>
+                  </a:txBody>
+                  <a:tcPr>
+                    <a:solidFill>
+                      <a:srgbClr val="4466AA"/>
+                    </a:solidFill>
+                  </a:tcPr>
+                </a:tc>
+                <a:tc>
+                  <a:txBody>
+                    <a:bodyPr/>
+                    <a:lstStyle/>
+                    <a:p>
+                      <a:pPr>
+                        <a:defRPr sz="1400" b="1">
+                          <a:solidFill>
+                            <a:srgbClr val="FFFFFF"/>
+                          </a:solidFill>
+                        </a:defRPr>
+                      </a:pPr>
+                      <a:r>
+                        <a:t>PM (g/km)</a:t>
+                      </a:r>
+                    </a:p>
+                  </a:txBody>
+                  <a:tcPr>
+                    <a:solidFill>
+                      <a:srgbClr val="4466AA"/>
+                    </a:solidFill>
+                  </a:tcPr>
+                </a:tc>
+              </a:tr>
+              <a:tr h="411480">
+                <a:tc>
+                  <a:txBody>
+                    <a:bodyPr/>
+                    <a:lstStyle/>
+                    <a:p>
+                      <a:pPr>
+                        <a:defRPr sz="1400">
+                          <a:solidFill>
+                            <a:srgbClr val="111111"/>
+                          </a:solidFill>
+                        </a:defRPr>
+                      </a:pPr>
+                      <a:r>
+                        <a:t>motorbike</a:t>
+                      </a:r>
+                    </a:p>
+                  </a:txBody>
+                  <a:tcPr>
+                    <a:solidFill>
+                      <a:srgbClr val="F2F6FF"/>
+                    </a:solidFill>
+                  </a:tcPr>
+                </a:tc>
+                <a:tc>
+                  <a:txBody>
+                    <a:bodyPr/>
+                    <a:lstStyle/>
+                    <a:p>
+                      <a:pPr>
+                        <a:defRPr sz="1400">
+                          <a:solidFill>
+                            <a:srgbClr val="111111"/>
+                          </a:solidFill>
+                        </a:defRPr>
+                      </a:pPr>
+                      <a:r>
+                        <a:t>3.62</a:t>
+                      </a:r>
+                    </a:p>
+                  </a:txBody>
+                  <a:tcPr>
+                    <a:solidFill>
+                      <a:srgbClr val="F2F6FF"/>
+                    </a:solidFill>
+                  </a:tcPr>
+                </a:tc>
+                <a:tc>
+                  <a:txBody>
+                    <a:bodyPr/>
+                    <a:lstStyle/>
+                    <a:p>
+                      <a:pPr>
+                        <a:defRPr sz="1400">
+                          <a:solidFill>
+                            <a:srgbClr val="111111"/>
+                          </a:solidFill>
+                        </a:defRPr>
+                      </a:pPr>
+                      <a:r>
+                        <a:t>0.3</a:t>
+                      </a:r>
+                    </a:p>
+                  </a:txBody>
+                  <a:tcPr>
+                    <a:solidFill>
+                      <a:srgbClr val="F2F6FF"/>
+                    </a:solidFill>
+                  </a:tcPr>
+                </a:tc>
+                <a:tc>
+                  <a:txBody>
+                    <a:bodyPr/>
+                    <a:lstStyle/>
+                    <a:p>
+                      <a:pPr>
+                        <a:defRPr sz="1400">
+                          <a:solidFill>
+                            <a:srgbClr val="111111"/>
+                          </a:solidFill>
+                        </a:defRPr>
+                      </a:pPr>
+                      <a:r>
+                        <a:t>0.03</a:t>
+                      </a:r>
+                    </a:p>
+                  </a:txBody>
+                  <a:tcPr>
+                    <a:solidFill>
+                      <a:srgbClr val="F2F6FF"/>
+                    </a:solidFill>
+                  </a:tcPr>
+                </a:tc>
+                <a:tc>
+                  <a:txBody>
+                    <a:bodyPr/>
+                    <a:lstStyle/>
+                    <a:p>
+                      <a:pPr>
+                        <a:defRPr sz="1400">
+                          <a:solidFill>
+                            <a:srgbClr val="111111"/>
+                          </a:solidFill>
+                        </a:defRPr>
+                      </a:pPr>
+                      <a:r>
+                        <a:t>0.1</a:t>
+                      </a:r>
+                    </a:p>
+                  </a:txBody>
+                  <a:tcPr>
+                    <a:solidFill>
+                      <a:srgbClr val="F2F6FF"/>
+                    </a:solidFill>
+                  </a:tcPr>
+                </a:tc>
+              </a:tr>
+              <a:tr h="411480">
+                <a:tc>
+                  <a:txBody>
+                    <a:bodyPr/>
+                    <a:lstStyle/>
+                    <a:p>
+                      <a:pPr>
+                        <a:defRPr sz="1400">
+                          <a:solidFill>
+                            <a:srgbClr val="111111"/>
+                          </a:solidFill>
+                        </a:defRPr>
+                      </a:pPr>
+                      <a:r>
+                        <a:t>car</a:t>
+                      </a:r>
+                    </a:p>
+                  </a:txBody>
+                  <a:tcPr>
+                    <a:solidFill>
+                      <a:srgbClr val="FFFFFF"/>
+                    </a:solidFill>
+                  </a:tcPr>
+                </a:tc>
+                <a:tc>
+                  <a:txBody>
+                    <a:bodyPr/>
+                    <a:lstStyle/>
+                    <a:p>
+                      <a:pPr>
+                        <a:defRPr sz="1400">
+                          <a:solidFill>
+                            <a:srgbClr val="111111"/>
+                          </a:solidFill>
+                        </a:defRPr>
+                      </a:pPr>
+                      <a:r>
+                        <a:t>3.62</a:t>
+                      </a:r>
+                    </a:p>
+                  </a:txBody>
+                  <a:tcPr>
+                    <a:solidFill>
+                      <a:srgbClr val="FFFFFF"/>
+                    </a:solidFill>
+                  </a:tcPr>
+                </a:tc>
+                <a:tc>
+                  <a:txBody>
+                    <a:bodyPr/>
+                    <a:lstStyle/>
+                    <a:p>
+                      <a:pPr>
+                        <a:defRPr sz="1400">
+                          <a:solidFill>
+                            <a:srgbClr val="111111"/>
+                          </a:solidFill>
+                        </a:defRPr>
+                      </a:pPr>
+                      <a:r>
+                        <a:t>1.5</a:t>
+                      </a:r>
+                    </a:p>
+                  </a:txBody>
+                  <a:tcPr>
+                    <a:solidFill>
+                      <a:srgbClr val="FFFFFF"/>
+                    </a:solidFill>
+                  </a:tcPr>
+                </a:tc>
+                <a:tc>
+                  <a:txBody>
+                    <a:bodyPr/>
+                    <a:lstStyle/>
+                    <a:p>
+                      <a:pPr>
+                        <a:defRPr sz="1400">
+                          <a:solidFill>
+                            <a:srgbClr val="111111"/>
+                          </a:solidFill>
+                        </a:defRPr>
+                      </a:pPr>
+                      <a:r>
+                        <a:t>0.17</a:t>
+                      </a:r>
+                    </a:p>
+                  </a:txBody>
+                  <a:tcPr>
+                    <a:solidFill>
+                      <a:srgbClr val="FFFFFF"/>
+                    </a:solidFill>
+                  </a:tcPr>
+                </a:tc>
+                <a:tc>
+                  <a:txBody>
+                    <a:bodyPr/>
+                    <a:lstStyle/>
+                    <a:p>
+                      <a:pPr>
+                        <a:defRPr sz="1400">
+                          <a:solidFill>
+                            <a:srgbClr val="111111"/>
+                          </a:solidFill>
+                        </a:defRPr>
+                      </a:pPr>
+                      <a:r>
+                        <a:t>0.1</a:t>
+                      </a:r>
+                    </a:p>
+                  </a:txBody>
+                  <a:tcPr>
+                    <a:solidFill>
+                      <a:srgbClr val="FFFFFF"/>
+                    </a:solidFill>
+                  </a:tcPr>
+                </a:tc>
+              </a:tr>
+              <a:tr h="411480">
+                <a:tc>
+                  <a:txBody>
+                    <a:bodyPr/>
+                    <a:lstStyle/>
+                    <a:p>
+                      <a:pPr>
+                        <a:defRPr sz="1400">
+                          <a:solidFill>
+                            <a:srgbClr val="111111"/>
+                          </a:solidFill>
+                        </a:defRPr>
+                      </a:pPr>
+                      <a:r>
+                        <a:t>bus</a:t>
+                      </a:r>
+                    </a:p>
+                  </a:txBody>
+                  <a:tcPr>
+                    <a:solidFill>
+                      <a:srgbClr val="F2F6FF"/>
+                    </a:solidFill>
+                  </a:tcPr>
+                </a:tc>
+                <a:tc>
+                  <a:txBody>
+                    <a:bodyPr/>
+                    <a:lstStyle/>
+                    <a:p>
+                      <a:pPr>
+                        <a:defRPr sz="1400">
+                          <a:solidFill>
+                            <a:srgbClr val="111111"/>
+                          </a:solidFill>
+                        </a:defRPr>
+                      </a:pPr>
+                      <a:r>
+                        <a:t>13.0</a:t>
+                      </a:r>
+                    </a:p>
+                  </a:txBody>
+                  <a:tcPr>
+                    <a:solidFill>
+                      <a:srgbClr val="F2F6FF"/>
+                    </a:solidFill>
+                  </a:tcPr>
+                </a:tc>
+                <a:tc>
+                  <a:txBody>
+                    <a:bodyPr/>
+                    <a:lstStyle/>
+                    <a:p>
+                      <a:pPr>
+                        <a:defRPr sz="1400">
+                          <a:solidFill>
+                            <a:srgbClr val="111111"/>
+                          </a:solidFill>
+                        </a:defRPr>
+                      </a:pPr>
+                      <a:r>
+                        <a:t>7.0</a:t>
+                      </a:r>
+                    </a:p>
+                  </a:txBody>
+                  <a:tcPr>
+                    <a:solidFill>
+                      <a:srgbClr val="F2F6FF"/>
+                    </a:solidFill>
+                  </a:tcPr>
+                </a:tc>
+                <a:tc>
+                  <a:txBody>
+                    <a:bodyPr/>
+                    <a:lstStyle/>
+                    <a:p>
+                      <a:pPr>
+                        <a:defRPr sz="1400">
+                          <a:solidFill>
+                            <a:srgbClr val="111111"/>
+                          </a:solidFill>
+                        </a:defRPr>
+                      </a:pPr>
+                      <a:r>
+                        <a:t>0.5</a:t>
+                      </a:r>
+                    </a:p>
+                  </a:txBody>
+                  <a:tcPr>
+                    <a:solidFill>
+                      <a:srgbClr val="F2F6FF"/>
+                    </a:solidFill>
+                  </a:tcPr>
+                </a:tc>
+                <a:tc>
+                  <a:txBody>
+                    <a:bodyPr/>
+                    <a:lstStyle/>
+                    <a:p>
+                      <a:pPr>
+                        <a:defRPr sz="1400">
+                          <a:solidFill>
+                            <a:srgbClr val="111111"/>
+                          </a:solidFill>
+                        </a:defRPr>
+                      </a:pPr>
+                      <a:r>
+                        <a:t>0.9</a:t>
+                      </a:r>
+                    </a:p>
+                  </a:txBody>
+                  <a:tcPr>
+                    <a:solidFill>
+                      <a:srgbClr val="F2F6FF"/>
+                    </a:solidFill>
+                  </a:tcPr>
+                </a:tc>
+              </a:tr>
+              <a:tr h="411480">
+                <a:tc>
+                  <a:txBody>
+                    <a:bodyPr/>
+                    <a:lstStyle/>
+                    <a:p>
+                      <a:pPr>
+                        <a:defRPr sz="1400">
+                          <a:solidFill>
+                            <a:srgbClr val="111111"/>
+                          </a:solidFill>
+                        </a:defRPr>
+                      </a:pPr>
+                      <a:r>
+                        <a:t>lorry</a:t>
+                      </a:r>
+                    </a:p>
+                  </a:txBody>
+                  <a:tcPr>
+                    <a:solidFill>
+                      <a:srgbClr val="FFFFFF"/>
+                    </a:solidFill>
+                  </a:tcPr>
+                </a:tc>
+                <a:tc>
+                  <a:txBody>
+                    <a:bodyPr/>
+                    <a:lstStyle/>
+                    <a:p>
+                      <a:pPr>
+                        <a:defRPr sz="1400">
+                          <a:solidFill>
+                            <a:srgbClr val="111111"/>
+                          </a:solidFill>
+                        </a:defRPr>
+                      </a:pPr>
+                      <a:r>
+                        <a:t>15.0</a:t>
+                      </a:r>
+                    </a:p>
+                  </a:txBody>
+                  <a:tcPr>
+                    <a:solidFill>
+                      <a:srgbClr val="FFFFFF"/>
+                    </a:solidFill>
+                  </a:tcPr>
+                </a:tc>
+                <a:tc>
+                  <a:txBody>
+                    <a:bodyPr/>
+                    <a:lstStyle/>
+                    <a:p>
+                      <a:pPr>
+                        <a:defRPr sz="1400">
+                          <a:solidFill>
+                            <a:srgbClr val="111111"/>
+                          </a:solidFill>
+                        </a:defRPr>
+                      </a:pPr>
+                      <a:r>
+                        <a:t>9.0</a:t>
+                      </a:r>
+                    </a:p>
+                  </a:txBody>
+                  <a:tcPr>
+                    <a:solidFill>
+                      <a:srgbClr val="FFFFFF"/>
+                    </a:solidFill>
+                  </a:tcPr>
+                </a:tc>
+                <a:tc>
+                  <a:txBody>
+                    <a:bodyPr/>
+                    <a:lstStyle/>
+                    <a:p>
+                      <a:pPr>
+                        <a:defRPr sz="1400">
+                          <a:solidFill>
+                            <a:srgbClr val="111111"/>
+                          </a:solidFill>
+                        </a:defRPr>
+                      </a:pPr>
+                      <a:r>
+                        <a:t>0.6</a:t>
+                      </a:r>
+                    </a:p>
+                  </a:txBody>
+                  <a:tcPr>
+                    <a:solidFill>
+                      <a:srgbClr val="FFFFFF"/>
+                    </a:solidFill>
+                  </a:tcPr>
+                </a:tc>
+                <a:tc>
+                  <a:txBody>
+                    <a:bodyPr/>
+                    <a:lstStyle/>
+                    <a:p>
+                      <a:pPr>
+                        <a:defRPr sz="1400">
+                          <a:solidFill>
+                            <a:srgbClr val="111111"/>
+                          </a:solidFill>
+                        </a:defRPr>
+                      </a:pPr>
+                      <a:r>
+                        <a:t>1.0</a:t>
+                      </a:r>
+                    </a:p>
+                  </a:txBody>
+                  <a:tcPr>
+                    <a:solidFill>
+                      <a:srgbClr val="FFFFFF"/>
+                    </a:solidFill>
+                  </a:tcPr>
+                </a:tc>
+              </a:tr>
+            </a:tbl>
+          </a:graphicData>
+        </a:graphic>
+      </p:graphicFrame>
+      <p:sp>
+        <p:nvSpPr>
+          <p:cNvPr id="5" name="TextBox 4"/>
+          <p:cNvSpPr txBox="1"/>
+          <p:nvPr/>
+        </p:nvSpPr>
+        <p:spPr>
+          <a:xfrm>
+            <a:off x="548640" y="5212080"/>
+            <a:ext cx="8046720" cy="914400"/>
+          </a:xfrm>
+          <a:prstGeom prst="rect">
+            <a:avLst/>
+          </a:prstGeom>
+          <a:noFill/>
+        </p:spPr>
+        <p:txBody>
+          <a:bodyPr wrap="none">
+            <a:spAutoFit/>
+          </a:bodyPr>
+          <a:lstStyle/>
+          <a:p>
+            <a:pPr>
+              <a:defRPr sz="1500" b="1">
+                <a:solidFill>
+                  <a:srgbClr val="333333"/>
+                </a:solidFill>
+              </a:defRPr>
+            </a:pPr>
+            <a:r>
+              <a:t>Key idea: buses and lorries are the heavy polluters (PM+NOx sits ~an order of magnitude above a car). Lowering EMISSION_SCALE from 0.2 to 0.15 cuts every type by about 25%.</a:t>
             </a:r>
           </a:p>
         </p:txBody>
@@ -5013,7 +5692,7 @@
           <a:lstStyle/>
           <a:p>
             <a:r>
-              <a:t>Buildings &amp; Visuals (For Clarity)</a:t>
+              <a:t>9. agents/visualization.gaml – What We See</a:t>
             </a:r>
           </a:p>
         </p:txBody>
@@ -5037,23 +5716,39 @@
               <a:defRPr sz="1800"/>
             </a:pPr>
             <a:r>
-              <a:t>Buildings loaded from shapefile to show urban area (city context).</a:t>
-            </a:r>
-          </a:p>
-          <a:p>
-            <a:pPr>
-              <a:defRPr sz="1800"/>
-            </a:pPr>
-            <a:r>
-              <a:t>Given small depth/varied textures to look nicer on map (visual only, not affecting simulation).</a:t>
-            </a:r>
-          </a:p>
-          <a:p>
-            <a:pPr>
-              <a:defRPr sz="1800"/>
-            </a:pPr>
-            <a:r>
-              <a:t>Helps us recognise areas (George Town/Penang urban layout).</a:t>
+              <a:t>Purpose: Turns numbers/agents into a VISUAL MAP + CHARTS (the GUI you see).</a:t>
+            </a:r>
+          </a:p>
+          <a:p>
+            <a:pPr>
+              <a:defRPr sz="1800"/>
+            </a:pPr>
+            <a:r>
+              <a:t>Shows: Penang map background, roads, buildings, vehicles moving, pollution layer (colours), study boundary.</a:t>
+            </a:r>
+          </a:p>
+          <a:p>
+            <a:pPr>
+              <a:defRPr sz="1800"/>
+            </a:pPr>
+            <a:r>
+              <a:t>Charts: AQI/pollution over TIME (line graph).</a:t>
+            </a:r>
+          </a:p>
+          <a:p>
+            <a:pPr>
+              <a:defRPr sz="1800"/>
+            </a:pPr>
+            <a:r>
+              <a:t>UI: Indicators (Time), progress bars (vehicle counts/mix).</a:t>
+            </a:r>
+          </a:p>
+          <a:p>
+            <a:pPr>
+              <a:defRPr sz="1800"/>
+            </a:pPr>
+            <a:r>
+              <a:t>Key Idea: Makes the invisible (pollution levels) VISIBLE on screen.</a:t>
             </a:r>
           </a:p>
         </p:txBody>
@@ -5092,7 +5787,7 @@
           <a:lstStyle/>
           <a:p>
             <a:r>
-              <a:t>Time &amp; AQI (How We Track Changes Over Time)</a:t>
+              <a:t>Buildings &amp; Visuals (For Clarity)</a:t>
             </a:r>
           </a:p>
         </p:txBody>
@@ -5116,39 +5811,23 @@
               <a:defRPr sz="1800"/>
             </a:pPr>
             <a:r>
-              <a:t>Simulation runs STEP-BY-STEP (time passes in simulation).</a:t>
-            </a:r>
-          </a:p>
-          <a:p>
-            <a:pPr>
-              <a:defRPr sz="1800"/>
-            </a:pPr>
-            <a:r>
-              <a:t>Clock updates on screen (shows current simulation time).</a:t>
-            </a:r>
-          </a:p>
-          <a:p>
-            <a:pPr>
-              <a:defRPr sz="1800"/>
-            </a:pPr>
-            <a:r>
-              <a:t>AQI (Air Quality Indicator): Tracks MAXIMUM pollution level in the study area at intervals.</a:t>
-            </a:r>
-          </a:p>
-          <a:p>
-            <a:pPr>
-              <a:defRPr sz="1800"/>
-            </a:pPr>
-            <a:r>
-              <a:t>Plotted as a LINE GRAPH over time (shows trends: when does pollution go up/down?).</a:t>
-            </a:r>
-          </a:p>
-          <a:p>
-            <a:pPr>
-              <a:defRPr sz="1800"/>
-            </a:pPr>
-            <a:r>
-              <a:t>Key Idea: See HOW pollution changes over TIME, not just a single snapshot.</a:t>
+              <a:t>Buildings loaded from shapefile to show urban area (city context).</a:t>
+            </a:r>
+          </a:p>
+          <a:p>
+            <a:pPr>
+              <a:defRPr sz="1800"/>
+            </a:pPr>
+            <a:r>
+              <a:t>Given small depth/varied textures to look nicer on map (visual only, not affecting simulation).</a:t>
+            </a:r>
+          </a:p>
+          <a:p>
+            <a:pPr>
+              <a:defRPr sz="1800"/>
+            </a:pPr>
+            <a:r>
+              <a:t>Helps us recognise areas (George Town/Penang urban layout).</a:t>
             </a:r>
           </a:p>
         </p:txBody>
@@ -5187,7 +5866,7 @@
           <a:lstStyle/>
           <a:p>
             <a:r>
-              <a:t>Full Story: Step-by-Step (Start → End)</a:t>
+              <a:t>Time &amp; AQI (How We Track Changes Over Time)</a:t>
             </a:r>
           </a:p>
         </p:txBody>
@@ -5211,55 +5890,39 @@
               <a:defRPr sz="1800"/>
             </a:pPr>
             <a:r>
-              <a:t>STEP 1: Start (PenangAir.gaml) – Open model, press Run.</a:t>
-            </a:r>
-          </a:p>
-          <a:p>
-            <a:pPr>
-              <a:defRPr sz="1800"/>
-            </a:pPr>
-            <a:r>
-              <a:t>STEP 2: Load Settings (global_vars) – Read rules/numbers.</a:t>
-            </a:r>
-          </a:p>
-          <a:p>
-            <a:pPr>
-              <a:defRPr sz="1800"/>
-            </a:pPr>
-            <a:r>
-              <a:t>STEP 3: Load Map (in main.gaml) – Load real Penang roads+buildings.</a:t>
-            </a:r>
-          </a:p>
-          <a:p>
-            <a:pPr>
-              <a:defRPr sz="1800"/>
-            </a:pPr>
-            <a:r>
-              <a:t>STEP 4: Get Ready (main.gaml init) – Clean road network, prepare study area.</a:t>
-            </a:r>
-          </a:p>
-          <a:p>
-            <a:pPr>
-              <a:defRPr sz="1800"/>
-            </a:pPr>
-            <a:r>
-              <a:t>STEP 5: Load Real Traffic? Check tttt==1 → Read traffic_counts.csv.</a:t>
-            </a:r>
-          </a:p>
-          <a:p>
-            <a:pPr>
-              <a:defRPr sz="1800"/>
-            </a:pPr>
-            <a:r>
-              <a:t>STEP 6: Create Vehicles – Spawn cars/bikes/buses/lorries on roads (by name or road type).</a:t>
-            </a:r>
-          </a:p>
-          <a:p>
-            <a:pPr>
-              <a:defRPr sz="1800"/>
-            </a:pPr>
-            <a:r>
-              <a:t>STEP 7: Press PLAY (Time Starts) – Simulation runs step-by-step.</a:t>
+              <a:t>Simulation runs STEP-BY-STEP (time passes in simulation).</a:t>
+            </a:r>
+          </a:p>
+          <a:p>
+            <a:pPr>
+              <a:defRPr sz="1800"/>
+            </a:pPr>
+            <a:r>
+              <a:t>Clock updates on screen (shows current simulation time).</a:t>
+            </a:r>
+          </a:p>
+          <a:p>
+            <a:pPr>
+              <a:defRPr sz="1800"/>
+            </a:pPr>
+            <a:r>
+              <a:t>AQI (Air Quality Indicator): Tracks MAXIMUM pollution level in the study area at intervals.</a:t>
+            </a:r>
+          </a:p>
+          <a:p>
+            <a:pPr>
+              <a:defRPr sz="1800"/>
+            </a:pPr>
+            <a:r>
+              <a:t>Plotted as a LINE GRAPH over time (shows trends: when does pollution go up/down?).</a:t>
+            </a:r>
+          </a:p>
+          <a:p>
+            <a:pPr>
+              <a:defRPr sz="1800"/>
+            </a:pPr>
+            <a:r>
+              <a:t>Key Idea: See HOW pollution changes over TIME, not just a single snapshot.</a:t>
             </a:r>
           </a:p>
         </p:txBody>
@@ -5298,7 +5961,7 @@
           <a:lstStyle/>
           <a:p>
             <a:r>
-              <a:t>Full Story: Step-by-Step (Runtime)</a:t>
+              <a:t>Full Story: Step-by-Step (Start → End)</a:t>
             </a:r>
           </a:p>
         </p:txBody>
@@ -5322,39 +5985,55 @@
               <a:defRPr sz="1800"/>
             </a:pPr>
             <a:r>
-              <a:t>STEP 8: Traffic Moves (traffic.gaml) – Vehicles travel along roads over time (traffic flows).</a:t>
-            </a:r>
-          </a:p>
-          <a:p>
-            <a:pPr>
-              <a:defRPr sz="1800"/>
-            </a:pPr>
-            <a:r>
-              <a:t>STEP 9: Pollution Updates (pollution.gaml) – Emissions calculated from traffic → Pollution field updated → Hotspots appear/change.</a:t>
-            </a:r>
-          </a:p>
-          <a:p>
-            <a:pPr>
-              <a:defRPr sz="1800"/>
-            </a:pPr>
-            <a:r>
-              <a:t>STEP 10: Update Time &amp; AQI (main.gaml) – Clock updates, pollution trend chart updates.</a:t>
-            </a:r>
-          </a:p>
-          <a:p>
-            <a:pPr>
-              <a:defRPr sz="1800"/>
-            </a:pPr>
-            <a:r>
-              <a:t>STEP 11: Visualize (visualization.gaml) – Map, vehicles, pollution colours, charts all update in REAL-TIME.</a:t>
-            </a:r>
-          </a:p>
-          <a:p>
-            <a:pPr>
-              <a:defRPr sz="1800"/>
-            </a:pPr>
-            <a:r>
-              <a:t>STEP 12: Observe – Watch patterns emerge (cause–effect: traffic → pollution).</a:t>
+              <a:t>STEP 1: Start (PenangAir.gaml) – Open model, press Run.</a:t>
+            </a:r>
+          </a:p>
+          <a:p>
+            <a:pPr>
+              <a:defRPr sz="1800"/>
+            </a:pPr>
+            <a:r>
+              <a:t>STEP 2: Load Settings (global_vars) – Read rules/numbers.</a:t>
+            </a:r>
+          </a:p>
+          <a:p>
+            <a:pPr>
+              <a:defRPr sz="1800"/>
+            </a:pPr>
+            <a:r>
+              <a:t>STEP 3: Load Map (in main.gaml) – Load real Penang roads+buildings.</a:t>
+            </a:r>
+          </a:p>
+          <a:p>
+            <a:pPr>
+              <a:defRPr sz="1800"/>
+            </a:pPr>
+            <a:r>
+              <a:t>STEP 4: Get Ready (main.gaml init) – Clean road network, prepare study area.</a:t>
+            </a:r>
+          </a:p>
+          <a:p>
+            <a:pPr>
+              <a:defRPr sz="1800"/>
+            </a:pPr>
+            <a:r>
+              <a:t>STEP 5: Load Real Traffic? Check use_traffic_data == 1 → Read traffic_counts.csv.</a:t>
+            </a:r>
+          </a:p>
+          <a:p>
+            <a:pPr>
+              <a:defRPr sz="1800"/>
+            </a:pPr>
+            <a:r>
+              <a:t>STEP 6: Create Vehicles – Spawn cars/bikes/buses/lorries on roads (by name or road type).</a:t>
+            </a:r>
+          </a:p>
+          <a:p>
+            <a:pPr>
+              <a:defRPr sz="1800"/>
+            </a:pPr>
+            <a:r>
+              <a:t>STEP 7: Press PLAY (Time Starts) – Simulation runs step-by-step.</a:t>
             </a:r>
           </a:p>
         </p:txBody>
@@ -5393,7 +6072,7 @@
           <a:lstStyle/>
           <a:p>
             <a:r>
-              <a:t>The Cause–Effect Chain (Most Important)</a:t>
+              <a:t>Full Story: Step-by-Step (Runtime)</a:t>
             </a:r>
           </a:p>
         </p:txBody>
@@ -5417,87 +6096,39 @@
               <a:defRPr sz="1800"/>
             </a:pPr>
             <a:r>
-              <a:t>REAL MAP (Geography)</a:t>
-            </a:r>
-          </a:p>
-          <a:p>
-            <a:pPr>
-              <a:defRPr sz="1800"/>
-            </a:pPr>
-            <a:r>
-              <a:t>↓</a:t>
-            </a:r>
-          </a:p>
-          <a:p>
-            <a:pPr>
-              <a:defRPr sz="1800"/>
-            </a:pPr>
-            <a:r>
-              <a:t>REAL TRAFFIC COUNTS (CSV) → Vehicles placed on roads</a:t>
-            </a:r>
-          </a:p>
-          <a:p>
-            <a:pPr>
-              <a:defRPr sz="1800"/>
-            </a:pPr>
-            <a:r>
-              <a:t>↓</a:t>
-            </a:r>
-          </a:p>
-          <a:p>
-            <a:pPr>
-              <a:defRPr sz="1800"/>
-            </a:pPr>
-            <a:r>
-              <a:t>VEHICLES MOVE (Traffic Flow)</a:t>
-            </a:r>
-          </a:p>
-          <a:p>
-            <a:pPr>
-              <a:defRPr sz="1800"/>
-            </a:pPr>
-            <a:r>
-              <a:t>↓</a:t>
-            </a:r>
-          </a:p>
-          <a:p>
-            <a:pPr>
-              <a:defRPr sz="1800"/>
-            </a:pPr>
-            <a:r>
-              <a:t>TRAFFIC ACTIVITY creates EMISSIONS</a:t>
-            </a:r>
-          </a:p>
-          <a:p>
-            <a:pPr>
-              <a:defRPr sz="1800"/>
-            </a:pPr>
-            <a:r>
-              <a:t>↓</a:t>
-            </a:r>
-          </a:p>
-          <a:p>
-            <a:pPr>
-              <a:defRPr sz="1800"/>
-            </a:pPr>
-            <a:r>
-              <a:t>EMISSIONS become AIR POLLUTION (spatial hotspots)</a:t>
-            </a:r>
-          </a:p>
-          <a:p>
-            <a:pPr>
-              <a:defRPr sz="1800"/>
-            </a:pPr>
-            <a:r>
-              <a:t>↓</a:t>
-            </a:r>
-          </a:p>
-          <a:p>
-            <a:pPr>
-              <a:defRPr sz="1800"/>
-            </a:pPr>
-            <a:r>
-              <a:t>WE SEE IT ON MAP + CHARTS (Visualization)</a:t>
+              <a:t>STEP 8: Traffic Moves (traffic.gaml) – Vehicles travel along roads over time (traffic flows).</a:t>
+            </a:r>
+          </a:p>
+          <a:p>
+            <a:pPr>
+              <a:defRPr sz="1800"/>
+            </a:pPr>
+            <a:r>
+              <a:t>STEP 9: Pollution Updates (pollution.gaml) – Emissions calculated from traffic → Pollution field updated → Hotspots appear/change.</a:t>
+            </a:r>
+          </a:p>
+          <a:p>
+            <a:pPr>
+              <a:defRPr sz="1800"/>
+            </a:pPr>
+            <a:r>
+              <a:t>STEP 10: Update Time &amp; AQI (main.gaml) – Clock updates, pollution trend chart updates.</a:t>
+            </a:r>
+          </a:p>
+          <a:p>
+            <a:pPr>
+              <a:defRPr sz="1800"/>
+            </a:pPr>
+            <a:r>
+              <a:t>STEP 11: Visualize (visualization.gaml) – Map, vehicles, pollution colours, charts all update in REAL-TIME.</a:t>
+            </a:r>
+          </a:p>
+          <a:p>
+            <a:pPr>
+              <a:defRPr sz="1800"/>
+            </a:pPr>
+            <a:r>
+              <a:t>STEP 12: Observe – Watch patterns emerge (cause–effect: traffic → pollution).</a:t>
             </a:r>
           </a:p>
         </p:txBody>
@@ -5536,7 +6167,7 @@
           <a:lstStyle/>
           <a:p>
             <a:r>
-              <a:t>Key Concepts in Plain Words</a:t>
+              <a:t>The Cause–Effect Chain (Most Important)</a:t>
             </a:r>
           </a:p>
         </p:txBody>
@@ -5560,47 +6191,87 @@
               <a:defRPr sz="1800"/>
             </a:pPr>
             <a:r>
-              <a:t>AGENTS: Individual things that act (each vehicle is an 'agent').</a:t>
-            </a:r>
-          </a:p>
-          <a:p>
-            <a:pPr>
-              <a:defRPr sz="1800"/>
-            </a:pPr>
-            <a:r>
-              <a:t>AGENT-BASED MODEL (ABM): Many simple agents follow rules → Complex patterns appear.</a:t>
-            </a:r>
-          </a:p>
-          <a:p>
-            <a:pPr>
-              <a:defRPr sz="1800"/>
-            </a:pPr>
-            <a:r>
-              <a:t>GIS: Real maps (roads/buildings) instead of imaginary grid.</a:t>
-            </a:r>
-          </a:p>
-          <a:p>
-            <a:pPr>
-              <a:defRPr sz="1800"/>
-            </a:pPr>
-            <a:r>
-              <a:t>SPATIAL: Location matters (pollution differs by place).</a:t>
-            </a:r>
-          </a:p>
-          <a:p>
-            <a:pPr>
-              <a:defRPr sz="1800"/>
-            </a:pPr>
-            <a:r>
-              <a:t>TIME-STEPPING: Simulation moves forward little by little (second by second).</a:t>
-            </a:r>
-          </a:p>
-          <a:p>
-            <a:pPr>
-              <a:defRPr sz="1800"/>
-            </a:pPr>
-            <a:r>
-              <a:t>EMERGENCE: We don't 'draw' hotspots – they appear from traffic behaviour.</a:t>
+              <a:t>REAL MAP (Geography)</a:t>
+            </a:r>
+          </a:p>
+          <a:p>
+            <a:pPr>
+              <a:defRPr sz="1800"/>
+            </a:pPr>
+            <a:r>
+              <a:t>↓</a:t>
+            </a:r>
+          </a:p>
+          <a:p>
+            <a:pPr>
+              <a:defRPr sz="1800"/>
+            </a:pPr>
+            <a:r>
+              <a:t>REAL TRAFFIC COUNTS (CSV) → Vehicles placed on roads</a:t>
+            </a:r>
+          </a:p>
+          <a:p>
+            <a:pPr>
+              <a:defRPr sz="1800"/>
+            </a:pPr>
+            <a:r>
+              <a:t>↓</a:t>
+            </a:r>
+          </a:p>
+          <a:p>
+            <a:pPr>
+              <a:defRPr sz="1800"/>
+            </a:pPr>
+            <a:r>
+              <a:t>VEHICLES MOVE (Traffic Flow)</a:t>
+            </a:r>
+          </a:p>
+          <a:p>
+            <a:pPr>
+              <a:defRPr sz="1800"/>
+            </a:pPr>
+            <a:r>
+              <a:t>↓</a:t>
+            </a:r>
+          </a:p>
+          <a:p>
+            <a:pPr>
+              <a:defRPr sz="1800"/>
+            </a:pPr>
+            <a:r>
+              <a:t>TRAFFIC ACTIVITY creates EMISSIONS</a:t>
+            </a:r>
+          </a:p>
+          <a:p>
+            <a:pPr>
+              <a:defRPr sz="1800"/>
+            </a:pPr>
+            <a:r>
+              <a:t>↓</a:t>
+            </a:r>
+          </a:p>
+          <a:p>
+            <a:pPr>
+              <a:defRPr sz="1800"/>
+            </a:pPr>
+            <a:r>
+              <a:t>EMISSIONS become AIR POLLUTION (spatial hotspots)</a:t>
+            </a:r>
+          </a:p>
+          <a:p>
+            <a:pPr>
+              <a:defRPr sz="1800"/>
+            </a:pPr>
+            <a:r>
+              <a:t>↓</a:t>
+            </a:r>
+          </a:p>
+          <a:p>
+            <a:pPr>
+              <a:defRPr sz="1800"/>
+            </a:pPr>
+            <a:r>
+              <a:t>WE SEE IT ON MAP + CHARTS (Visualization)</a:t>
             </a:r>
           </a:p>
         </p:txBody>
@@ -5639,7 +6310,7 @@
           <a:lstStyle/>
           <a:p>
             <a:r>
-              <a:t>Why These Design Choices? (Simple Reasons)</a:t>
+              <a:t>Key Concepts in Plain Words</a:t>
             </a:r>
           </a:p>
         </p:txBody>
@@ -5663,47 +6334,47 @@
               <a:defRPr sz="1800"/>
             </a:pPr>
             <a:r>
-              <a:t>Split into many files: Easier to understand each part separately (divide &amp; explain).</a:t>
-            </a:r>
-          </a:p>
-          <a:p>
-            <a:pPr>
-              <a:defRPr sz="1800"/>
-            </a:pPr>
-            <a:r>
-              <a:t>Name-first, then road-type fallback: Uses real data where possible, fills gaps sensibly.</a:t>
-            </a:r>
-          </a:p>
-          <a:p>
-            <a:pPr>
-              <a:defRPr sz="1800"/>
-            </a:pPr>
-            <a:r>
-              <a:t>Clean network (remove islands): Prevents vehicles getting stuck unrealistically.</a:t>
-            </a:r>
-          </a:p>
-          <a:p>
-            <a:pPr>
-              <a:defRPr sz="1800"/>
-            </a:pPr>
-            <a:r>
-              <a:t>Fractional carry: Keeps total traffic numbers accurate (doesn't lose vehicles).</a:t>
-            </a:r>
-          </a:p>
-          <a:p>
-            <a:pPr>
-              <a:defRPr sz="1800"/>
-            </a:pPr>
-            <a:r>
-              <a:t>Cap total vehicles (max_vehicles): Keeps model smooth for demos (keeps proportions same).</a:t>
-            </a:r>
-          </a:p>
-          <a:p>
-            <a:pPr>
-              <a:defRPr sz="1800"/>
-            </a:pPr>
-            <a:r>
-              <a:t>tttt switch: Can test real vs. simple traffic easily.</a:t>
+              <a:t>AGENTS: Individual things that act (each vehicle is an 'agent').</a:t>
+            </a:r>
+          </a:p>
+          <a:p>
+            <a:pPr>
+              <a:defRPr sz="1800"/>
+            </a:pPr>
+            <a:r>
+              <a:t>AGENT-BASED MODEL (ABM): Many simple agents follow rules → Complex patterns appear.</a:t>
+            </a:r>
+          </a:p>
+          <a:p>
+            <a:pPr>
+              <a:defRPr sz="1800"/>
+            </a:pPr>
+            <a:r>
+              <a:t>GIS: Real maps (roads/buildings) instead of imaginary grid.</a:t>
+            </a:r>
+          </a:p>
+          <a:p>
+            <a:pPr>
+              <a:defRPr sz="1800"/>
+            </a:pPr>
+            <a:r>
+              <a:t>SPATIAL: Location matters (pollution differs by place).</a:t>
+            </a:r>
+          </a:p>
+          <a:p>
+            <a:pPr>
+              <a:defRPr sz="1800"/>
+            </a:pPr>
+            <a:r>
+              <a:t>TIME-STEPPING: Simulation moves forward little by little (second by second).</a:t>
+            </a:r>
+          </a:p>
+          <a:p>
+            <a:pPr>
+              <a:defRPr sz="1800"/>
+            </a:pPr>
+            <a:r>
+              <a:t>EMERGENCE: We don't 'draw' hotspots – they appear from traffic behaviour.</a:t>
             </a:r>
           </a:p>
         </p:txBody>
@@ -5829,7 +6500,7 @@
           <a:lstStyle/>
           <a:p>
             <a:r>
-              <a:t>What to Look For When Running (Demo Guide)</a:t>
+              <a:t>Why These Design Choices? (Simple Reasons)</a:t>
             </a:r>
           </a:p>
         </p:txBody>
@@ -5853,47 +6524,47 @@
               <a:defRPr sz="1800"/>
             </a:pPr>
             <a:r>
-              <a:t>1. Map loads first: See Penang roads/buildings appear.</a:t>
-            </a:r>
-          </a:p>
-          <a:p>
-            <a:pPr>
-              <a:defRPr sz="1800"/>
-            </a:pPr>
-            <a:r>
-              <a:t>2. Vehicles appear: Cars/bikes/buses/lorries placed on roads (realistic distribution).</a:t>
-            </a:r>
-          </a:p>
-          <a:p>
-            <a:pPr>
-              <a:defRPr sz="1800"/>
-            </a:pPr>
-            <a:r>
-              <a:t>3. Press Play: Vehicles start MOVING along roads.</a:t>
-            </a:r>
-          </a:p>
-          <a:p>
-            <a:pPr>
-              <a:defRPr sz="1800"/>
-            </a:pPr>
-            <a:r>
-              <a:t>4. Watch colours: Pollution layer changes colour over time (hotspots forming).</a:t>
-            </a:r>
-          </a:p>
-          <a:p>
-            <a:pPr>
-              <a:defRPr sz="1800"/>
-            </a:pPr>
-            <a:r>
-              <a:t>5. Watch chart: AQI line graph goes up/down as traffic changes.</a:t>
-            </a:r>
-          </a:p>
-          <a:p>
-            <a:pPr>
-              <a:defRPr sz="1800"/>
-            </a:pPr>
-            <a:r>
-              <a:t>6. Notice pattern: Busy roads/junctions often show higher pollution.</a:t>
+              <a:t>Split into many files: Easier to understand each part separately (divide &amp; explain).</a:t>
+            </a:r>
+          </a:p>
+          <a:p>
+            <a:pPr>
+              <a:defRPr sz="1800"/>
+            </a:pPr>
+            <a:r>
+              <a:t>Name-first, then road-type fallback: Uses real data where possible, fills gaps sensibly.</a:t>
+            </a:r>
+          </a:p>
+          <a:p>
+            <a:pPr>
+              <a:defRPr sz="1800"/>
+            </a:pPr>
+            <a:r>
+              <a:t>Clean network (remove islands): Prevents vehicles getting stuck unrealistically.</a:t>
+            </a:r>
+          </a:p>
+          <a:p>
+            <a:pPr>
+              <a:defRPr sz="1800"/>
+            </a:pPr>
+            <a:r>
+              <a:t>Fractional carry: Keeps total traffic numbers accurate (doesn't lose vehicles).</a:t>
+            </a:r>
+          </a:p>
+          <a:p>
+            <a:pPr>
+              <a:defRPr sz="1800"/>
+            </a:pPr>
+            <a:r>
+              <a:t>Cap total vehicles (max_vehicles): Keeps model smooth for demos (keeps proportions same).</a:t>
+            </a:r>
+          </a:p>
+          <a:p>
+            <a:pPr>
+              <a:defRPr sz="1800"/>
+            </a:pPr>
+            <a:r>
+              <a:t>use_traffic_data switch: Can test real vs. simple traffic easily.</a:t>
             </a:r>
           </a:p>
         </p:txBody>
@@ -5932,7 +6603,7 @@
           <a:lstStyle/>
           <a:p>
             <a:r>
-              <a:t>Simple Summary (One Sentence Per Part)</a:t>
+              <a:t>What to Look For When Running (Demo Guide)</a:t>
             </a:r>
           </a:p>
         </p:txBody>
@@ -5956,63 +6627,47 @@
               <a:defRPr sz="1800"/>
             </a:pPr>
             <a:r>
-              <a:t>PenangAir.gaml = Starts everything (entry point).</a:t>
-            </a:r>
-          </a:p>
-          <a:p>
-            <a:pPr>
-              <a:defRPr sz="1800"/>
-            </a:pPr>
-            <a:r>
-              <a:t>global_vars.gaml = The control panel (settings).</a:t>
-            </a:r>
-          </a:p>
-          <a:p>
-            <a:pPr>
-              <a:defRPr sz="1800"/>
-            </a:pPr>
-            <a:r>
-              <a:t>main.gaml = Loads GIS data, cleans roads, builds vehicles, runs the clock.</a:t>
-            </a:r>
-          </a:p>
-          <a:p>
-            <a:pPr>
-              <a:defRPr sz="1800"/>
-            </a:pPr>
-            <a:r>
-              <a:t>agents/ folder holds traffic, pollution, and visualization behaviours.</a:t>
-            </a:r>
-          </a:p>
-          <a:p>
-            <a:pPr>
-              <a:defRPr sz="1800"/>
-            </a:pPr>
-            <a:r>
-              <a:t>traffic_counts.csv = Real traffic numbers (input data).</a:t>
-            </a:r>
-          </a:p>
-          <a:p>
-            <a:pPr>
-              <a:defRPr sz="1800"/>
-            </a:pPr>
-            <a:r>
-              <a:t>traffic.gaml = Vehicles move on roads (traffic).</a:t>
-            </a:r>
-          </a:p>
-          <a:p>
-            <a:pPr>
-              <a:defRPr sz="1800"/>
-            </a:pPr>
-            <a:r>
-              <a:t>pollution.gaml = Traffic → creates pollution (impact).</a:t>
-            </a:r>
-          </a:p>
-          <a:p>
-            <a:pPr>
-              <a:defRPr sz="1800"/>
-            </a:pPr>
-            <a:r>
-              <a:t>visualization.gaml = Shows everything on screen (what we see).</a:t>
+              <a:t>1. Map loads first: See Penang roads/buildings appear.</a:t>
+            </a:r>
+          </a:p>
+          <a:p>
+            <a:pPr>
+              <a:defRPr sz="1800"/>
+            </a:pPr>
+            <a:r>
+              <a:t>2. Vehicles appear: Cars/bikes/buses/lorries placed on roads (realistic distribution).</a:t>
+            </a:r>
+          </a:p>
+          <a:p>
+            <a:pPr>
+              <a:defRPr sz="1800"/>
+            </a:pPr>
+            <a:r>
+              <a:t>3. Press Play: Vehicles start MOVING along roads.</a:t>
+            </a:r>
+          </a:p>
+          <a:p>
+            <a:pPr>
+              <a:defRPr sz="1800"/>
+            </a:pPr>
+            <a:r>
+              <a:t>4. Watch colours: Pollution layer changes colour over time (hotspots forming).</a:t>
+            </a:r>
+          </a:p>
+          <a:p>
+            <a:pPr>
+              <a:defRPr sz="1800"/>
+            </a:pPr>
+            <a:r>
+              <a:t>5. Watch chart: AQI line graph goes up/down as traffic changes.</a:t>
+            </a:r>
+          </a:p>
+          <a:p>
+            <a:pPr>
+              <a:defRPr sz="1800"/>
+            </a:pPr>
+            <a:r>
+              <a:t>6. Notice pattern: Busy roads/junctions often show higher pollution.</a:t>
             </a:r>
           </a:p>
         </p:txBody>
@@ -6051,7 +6706,7 @@
           <a:lstStyle/>
           <a:p>
             <a:r>
-              <a:t>Key Takeaway (In One Sentence)</a:t>
+              <a:t>Simple Summary (One Sentence Per Part)</a:t>
             </a:r>
           </a:p>
         </p:txBody>
@@ -6075,7 +6730,63 @@
               <a:defRPr sz="1800"/>
             </a:pPr>
             <a:r>
-              <a:t>PenangAir uses REAL traffic data on a REAL map of Penang to show, visually, how traffic can create air pollution hotspots over time.</a:t>
+              <a:t>PenangAir.gaml = Starts everything (entry point).</a:t>
+            </a:r>
+          </a:p>
+          <a:p>
+            <a:pPr>
+              <a:defRPr sz="1800"/>
+            </a:pPr>
+            <a:r>
+              <a:t>global_vars.gaml = The control panel (settings).</a:t>
+            </a:r>
+          </a:p>
+          <a:p>
+            <a:pPr>
+              <a:defRPr sz="1800"/>
+            </a:pPr>
+            <a:r>
+              <a:t>main.gaml = Loads GIS data, cleans roads, builds vehicles, runs the clock.</a:t>
+            </a:r>
+          </a:p>
+          <a:p>
+            <a:pPr>
+              <a:defRPr sz="1800"/>
+            </a:pPr>
+            <a:r>
+              <a:t>agents/ folder holds traffic, pollution, and visualization behaviours.</a:t>
+            </a:r>
+          </a:p>
+          <a:p>
+            <a:pPr>
+              <a:defRPr sz="1800"/>
+            </a:pPr>
+            <a:r>
+              <a:t>traffic_counts.csv = Real traffic numbers (input data).</a:t>
+            </a:r>
+          </a:p>
+          <a:p>
+            <a:pPr>
+              <a:defRPr sz="1800"/>
+            </a:pPr>
+            <a:r>
+              <a:t>traffic.gaml = Vehicles move on roads (traffic).</a:t>
+            </a:r>
+          </a:p>
+          <a:p>
+            <a:pPr>
+              <a:defRPr sz="1800"/>
+            </a:pPr>
+            <a:r>
+              <a:t>pollution.gaml = Traffic → creates pollution (impact).</a:t>
+            </a:r>
+          </a:p>
+          <a:p>
+            <a:pPr>
+              <a:defRPr sz="1800"/>
+            </a:pPr>
+            <a:r>
+              <a:t>visualization.gaml = Shows everything on screen (what we see).</a:t>
             </a:r>
           </a:p>
         </p:txBody>
@@ -6089,6 +6800,69 @@
 </file>
 
 <file path=ppt/slides/slide33.xml><?xml version="1.0" encoding="utf-8"?>
+<p:sld xmlns:a="http://schemas.openxmlformats.org/drawingml/2006/main" xmlns:p="http://schemas.openxmlformats.org/presentationml/2006/main" xmlns:r="http://schemas.openxmlformats.org/officeDocument/2006/relationships">
+  <p:cSld>
+    <p:spTree>
+      <p:nvGrpSpPr>
+        <p:cNvPr id="1" name=""/>
+        <p:cNvGrpSpPr/>
+        <p:nvPr/>
+      </p:nvGrpSpPr>
+      <p:grpSpPr/>
+      <p:sp>
+        <p:nvSpPr>
+          <p:cNvPr id="2" name="Title 1"/>
+          <p:cNvSpPr>
+            <a:spLocks noGrp="1"/>
+          </p:cNvSpPr>
+          <p:nvPr>
+            <p:ph type="title"/>
+          </p:nvPr>
+        </p:nvSpPr>
+        <p:spPr/>
+        <p:txBody>
+          <a:bodyPr/>
+          <a:lstStyle/>
+          <a:p>
+            <a:r>
+              <a:t>Key Takeaway (In One Sentence)</a:t>
+            </a:r>
+          </a:p>
+        </p:txBody>
+      </p:sp>
+      <p:sp>
+        <p:nvSpPr>
+          <p:cNvPr id="3" name="Content Placeholder 2"/>
+          <p:cNvSpPr>
+            <a:spLocks noGrp="1"/>
+          </p:cNvSpPr>
+          <p:nvPr>
+            <p:ph idx="1"/>
+          </p:nvPr>
+        </p:nvSpPr>
+        <p:spPr/>
+        <p:txBody>
+          <a:bodyPr/>
+          <a:lstStyle/>
+          <a:p>
+            <a:pPr>
+              <a:defRPr sz="1800"/>
+            </a:pPr>
+            <a:r>
+              <a:t>PenangAir uses REAL traffic data on a REAL map of Penang to show, visually, how traffic can create air pollution hotspots over time.</a:t>
+            </a:r>
+          </a:p>
+        </p:txBody>
+      </p:sp>
+    </p:spTree>
+  </p:cSld>
+  <p:clrMapOvr>
+    <a:masterClrMapping/>
+  </p:clrMapOvr>
+</p:sld>
+</file>
+
+<file path=ppt/slides/slide34.xml><?xml version="1.0" encoding="utf-8"?>
 <p:sld xmlns:a="http://schemas.openxmlformats.org/drawingml/2006/main" xmlns:p="http://schemas.openxmlformats.org/presentationml/2006/main" xmlns:r="http://schemas.openxmlformats.org/officeDocument/2006/relationships">
   <p:cSld>
     <p:spTree>

</xml_diff>